<commit_message>
feat(review1): Add merged 32-slide presentation and ensure universal Calibri typography
</commit_message>
<xml_diff>
--- a/review_1_main/Slides_Muc_8_9_10_11_12.pptx
+++ b/review_1_main/Slides_Muc_8_9_10_11_12.pptx
@@ -3131,7 +3131,11 @@
           <a:bodyPr rtlCol="0" anchor="ctr"/>
           <a:lstStyle/>
           <a:p>
-            <a:pPr algn="ctr"/>
+            <a:pPr algn="ctr">
+              <a:defRPr>
+                <a:latin typeface="Calibri"/>
+              </a:defRPr>
+            </a:pPr>
           </a:p>
         </p:txBody>
       </p:sp>
@@ -3284,7 +3288,11 @@
           <a:bodyPr rtlCol="0" anchor="ctr"/>
           <a:lstStyle/>
           <a:p>
-            <a:pPr algn="ctr"/>
+            <a:pPr algn="ctr">
+              <a:defRPr>
+                <a:latin typeface="Calibri"/>
+              </a:defRPr>
+            </a:pPr>
           </a:p>
         </p:txBody>
       </p:sp>
@@ -3368,6 +3376,7 @@
                 <a:solidFill>
                   <a:srgbClr val="0F172A"/>
                 </a:solidFill>
+                <a:latin typeface="Calibri"/>
               </a:defRPr>
             </a:pPr>
             <a:r>
@@ -3383,6 +3392,7 @@
                 <a:solidFill>
                   <a:srgbClr val="334155"/>
                 </a:solidFill>
+                <a:latin typeface="Calibri"/>
               </a:defRPr>
             </a:pPr>
             <a:r>
@@ -3398,6 +3408,7 @@
                 <a:solidFill>
                   <a:srgbClr val="334155"/>
                 </a:solidFill>
+                <a:latin typeface="Calibri"/>
               </a:defRPr>
             </a:pPr>
             <a:r>
@@ -3413,6 +3424,7 @@
                 <a:solidFill>
                   <a:srgbClr val="334155"/>
                 </a:solidFill>
+                <a:latin typeface="Calibri"/>
               </a:defRPr>
             </a:pPr>
             <a:r>
@@ -3428,6 +3440,7 @@
                 <a:solidFill>
                   <a:srgbClr val="334155"/>
                 </a:solidFill>
+                <a:latin typeface="Calibri"/>
               </a:defRPr>
             </a:pPr>
             <a:r>
@@ -3477,7 +3490,11 @@
           <a:bodyPr rtlCol="0" anchor="ctr"/>
           <a:lstStyle/>
           <a:p>
-            <a:pPr algn="ctr"/>
+            <a:pPr algn="ctr">
+              <a:defRPr>
+                <a:latin typeface="Calibri"/>
+              </a:defRPr>
+            </a:pPr>
           </a:p>
         </p:txBody>
       </p:sp>
@@ -3561,6 +3578,7 @@
                 <a:solidFill>
                   <a:srgbClr val="0F172A"/>
                 </a:solidFill>
+                <a:latin typeface="Calibri"/>
               </a:defRPr>
             </a:pPr>
             <a:r>
@@ -3576,6 +3594,7 @@
                 <a:solidFill>
                   <a:srgbClr val="334155"/>
                 </a:solidFill>
+                <a:latin typeface="Calibri"/>
               </a:defRPr>
             </a:pPr>
             <a:r>
@@ -3591,6 +3610,7 @@
                 <a:solidFill>
                   <a:srgbClr val="334155"/>
                 </a:solidFill>
+                <a:latin typeface="Calibri"/>
               </a:defRPr>
             </a:pPr>
             <a:r>
@@ -3606,6 +3626,7 @@
                 <a:solidFill>
                   <a:srgbClr val="334155"/>
                 </a:solidFill>
+                <a:latin typeface="Calibri"/>
               </a:defRPr>
             </a:pPr>
             <a:r>
@@ -3621,6 +3642,7 @@
                 <a:solidFill>
                   <a:srgbClr val="334155"/>
                 </a:solidFill>
+                <a:latin typeface="Calibri"/>
               </a:defRPr>
             </a:pPr>
             <a:r>
@@ -3670,7 +3692,11 @@
           <a:bodyPr rtlCol="0" anchor="ctr"/>
           <a:lstStyle/>
           <a:p>
-            <a:pPr algn="ctr"/>
+            <a:pPr algn="ctr">
+              <a:defRPr>
+                <a:latin typeface="Calibri"/>
+              </a:defRPr>
+            </a:pPr>
           </a:p>
         </p:txBody>
       </p:sp>
@@ -3754,6 +3780,7 @@
                 <a:solidFill>
                   <a:srgbClr val="0F172A"/>
                 </a:solidFill>
+                <a:latin typeface="Calibri"/>
               </a:defRPr>
             </a:pPr>
             <a:r>
@@ -3769,6 +3796,7 @@
                 <a:solidFill>
                   <a:srgbClr val="334155"/>
                 </a:solidFill>
+                <a:latin typeface="Calibri"/>
               </a:defRPr>
             </a:pPr>
             <a:r>
@@ -3784,6 +3812,7 @@
                 <a:solidFill>
                   <a:srgbClr val="334155"/>
                 </a:solidFill>
+                <a:latin typeface="Calibri"/>
               </a:defRPr>
             </a:pPr>
             <a:r>
@@ -3799,6 +3828,7 @@
                 <a:solidFill>
                   <a:srgbClr val="334155"/>
                 </a:solidFill>
+                <a:latin typeface="Calibri"/>
               </a:defRPr>
             </a:pPr>
             <a:r>
@@ -3814,6 +3844,7 @@
                 <a:solidFill>
                   <a:srgbClr val="334155"/>
                 </a:solidFill>
+                <a:latin typeface="Calibri"/>
               </a:defRPr>
             </a:pPr>
             <a:r>
@@ -3863,7 +3894,11 @@
           <a:bodyPr rtlCol="0" anchor="ctr"/>
           <a:lstStyle/>
           <a:p>
-            <a:pPr algn="ctr"/>
+            <a:pPr algn="ctr">
+              <a:defRPr>
+                <a:latin typeface="Calibri"/>
+              </a:defRPr>
+            </a:pPr>
           </a:p>
         </p:txBody>
       </p:sp>
@@ -3947,6 +3982,7 @@
                 <a:solidFill>
                   <a:srgbClr val="0F172A"/>
                 </a:solidFill>
+                <a:latin typeface="Calibri"/>
               </a:defRPr>
             </a:pPr>
             <a:r>
@@ -3962,6 +3998,7 @@
                 <a:solidFill>
                   <a:srgbClr val="334155"/>
                 </a:solidFill>
+                <a:latin typeface="Calibri"/>
               </a:defRPr>
             </a:pPr>
             <a:r>
@@ -3977,6 +4014,7 @@
                 <a:solidFill>
                   <a:srgbClr val="334155"/>
                 </a:solidFill>
+                <a:latin typeface="Calibri"/>
               </a:defRPr>
             </a:pPr>
             <a:r>
@@ -3992,6 +4030,7 @@
                 <a:solidFill>
                   <a:srgbClr val="334155"/>
                 </a:solidFill>
+                <a:latin typeface="Calibri"/>
               </a:defRPr>
             </a:pPr>
             <a:r>
@@ -4007,6 +4046,7 @@
                 <a:solidFill>
                   <a:srgbClr val="334155"/>
                 </a:solidFill>
+                <a:latin typeface="Calibri"/>
               </a:defRPr>
             </a:pPr>
             <a:r>
@@ -4056,7 +4096,11 @@
           <a:bodyPr rtlCol="0" anchor="ctr"/>
           <a:lstStyle/>
           <a:p>
-            <a:pPr algn="ctr"/>
+            <a:pPr algn="ctr">
+              <a:defRPr>
+                <a:latin typeface="Calibri"/>
+              </a:defRPr>
+            </a:pPr>
           </a:p>
         </p:txBody>
       </p:sp>
@@ -4206,7 +4250,11 @@
           <a:bodyPr rtlCol="0" anchor="ctr"/>
           <a:lstStyle/>
           <a:p>
-            <a:pPr algn="ctr"/>
+            <a:pPr algn="ctr">
+              <a:defRPr>
+                <a:latin typeface="Calibri"/>
+              </a:defRPr>
+            </a:pPr>
           </a:p>
         </p:txBody>
       </p:sp>
@@ -4359,7 +4407,11 @@
           <a:bodyPr rtlCol="0" anchor="ctr"/>
           <a:lstStyle/>
           <a:p>
-            <a:pPr algn="ctr"/>
+            <a:pPr algn="ctr">
+              <a:defRPr>
+                <a:latin typeface="Calibri"/>
+              </a:defRPr>
+            </a:pPr>
           </a:p>
         </p:txBody>
       </p:sp>
@@ -4443,6 +4495,7 @@
                 <a:solidFill>
                   <a:srgbClr val="0F172A"/>
                 </a:solidFill>
+                <a:latin typeface="Calibri"/>
               </a:defRPr>
             </a:pPr>
             <a:r>
@@ -4458,6 +4511,7 @@
                 <a:solidFill>
                   <a:srgbClr val="334155"/>
                 </a:solidFill>
+                <a:latin typeface="Calibri"/>
               </a:defRPr>
             </a:pPr>
             <a:r>
@@ -4473,6 +4527,7 @@
                 <a:solidFill>
                   <a:srgbClr val="EA580C"/>
                 </a:solidFill>
+                <a:latin typeface="Calibri"/>
               </a:defRPr>
             </a:pPr>
             <a:r>
@@ -4522,7 +4577,11 @@
           <a:bodyPr rtlCol="0" anchor="ctr"/>
           <a:lstStyle/>
           <a:p>
-            <a:pPr algn="ctr"/>
+            <a:pPr algn="ctr">
+              <a:defRPr>
+                <a:latin typeface="Calibri"/>
+              </a:defRPr>
+            </a:pPr>
           </a:p>
         </p:txBody>
       </p:sp>
@@ -4606,6 +4665,7 @@
                 <a:solidFill>
                   <a:srgbClr val="0F172A"/>
                 </a:solidFill>
+                <a:latin typeface="Calibri"/>
               </a:defRPr>
             </a:pPr>
             <a:r>
@@ -4621,6 +4681,7 @@
                 <a:solidFill>
                   <a:srgbClr val="334155"/>
                 </a:solidFill>
+                <a:latin typeface="Calibri"/>
               </a:defRPr>
             </a:pPr>
             <a:r>
@@ -4636,6 +4697,7 @@
                 <a:solidFill>
                   <a:srgbClr val="2563EB"/>
                 </a:solidFill>
+                <a:latin typeface="Calibri"/>
               </a:defRPr>
             </a:pPr>
             <a:r>
@@ -4685,7 +4747,11 @@
           <a:bodyPr rtlCol="0" anchor="ctr"/>
           <a:lstStyle/>
           <a:p>
-            <a:pPr algn="ctr"/>
+            <a:pPr algn="ctr">
+              <a:defRPr>
+                <a:latin typeface="Calibri"/>
+              </a:defRPr>
+            </a:pPr>
           </a:p>
         </p:txBody>
       </p:sp>
@@ -4769,6 +4835,7 @@
                 <a:solidFill>
                   <a:srgbClr val="0F172A"/>
                 </a:solidFill>
+                <a:latin typeface="Calibri"/>
               </a:defRPr>
             </a:pPr>
             <a:r>
@@ -4784,6 +4851,7 @@
                 <a:solidFill>
                   <a:srgbClr val="334155"/>
                 </a:solidFill>
+                <a:latin typeface="Calibri"/>
               </a:defRPr>
             </a:pPr>
             <a:r>
@@ -4799,6 +4867,7 @@
                 <a:solidFill>
                   <a:srgbClr val="D97706"/>
                 </a:solidFill>
+                <a:latin typeface="Calibri"/>
               </a:defRPr>
             </a:pPr>
             <a:r>
@@ -4848,7 +4917,11 @@
           <a:bodyPr rtlCol="0" anchor="ctr"/>
           <a:lstStyle/>
           <a:p>
-            <a:pPr algn="ctr"/>
+            <a:pPr algn="ctr">
+              <a:defRPr>
+                <a:latin typeface="Calibri"/>
+              </a:defRPr>
+            </a:pPr>
           </a:p>
         </p:txBody>
       </p:sp>
@@ -4932,6 +5005,7 @@
                 <a:solidFill>
                   <a:srgbClr val="0F172A"/>
                 </a:solidFill>
+                <a:latin typeface="Calibri"/>
               </a:defRPr>
             </a:pPr>
             <a:r>
@@ -4947,6 +5021,7 @@
                 <a:solidFill>
                   <a:srgbClr val="334155"/>
                 </a:solidFill>
+                <a:latin typeface="Calibri"/>
               </a:defRPr>
             </a:pPr>
             <a:r>
@@ -4962,6 +5037,7 @@
                 <a:solidFill>
                   <a:srgbClr val="16A34A"/>
                 </a:solidFill>
+                <a:latin typeface="Calibri"/>
               </a:defRPr>
             </a:pPr>
             <a:r>
@@ -5011,7 +5087,11 @@
           <a:bodyPr rtlCol="0" anchor="ctr"/>
           <a:lstStyle/>
           <a:p>
-            <a:pPr algn="ctr"/>
+            <a:pPr algn="ctr">
+              <a:defRPr>
+                <a:latin typeface="Calibri"/>
+              </a:defRPr>
+            </a:pPr>
           </a:p>
         </p:txBody>
       </p:sp>
@@ -5095,6 +5175,7 @@
                 <a:solidFill>
                   <a:srgbClr val="0F172A"/>
                 </a:solidFill>
+                <a:latin typeface="Calibri"/>
               </a:defRPr>
             </a:pPr>
             <a:r>
@@ -5110,6 +5191,7 @@
                 <a:solidFill>
                   <a:srgbClr val="334155"/>
                 </a:solidFill>
+                <a:latin typeface="Calibri"/>
               </a:defRPr>
             </a:pPr>
             <a:r>
@@ -5125,6 +5207,7 @@
                 <a:solidFill>
                   <a:srgbClr val="7C3AED"/>
                 </a:solidFill>
+                <a:latin typeface="Calibri"/>
               </a:defRPr>
             </a:pPr>
             <a:r>
@@ -5174,7 +5257,11 @@
           <a:bodyPr rtlCol="0" anchor="ctr"/>
           <a:lstStyle/>
           <a:p>
-            <a:pPr algn="ctr"/>
+            <a:pPr algn="ctr">
+              <a:defRPr>
+                <a:latin typeface="Calibri"/>
+              </a:defRPr>
+            </a:pPr>
           </a:p>
         </p:txBody>
       </p:sp>
@@ -5258,6 +5345,7 @@
                 <a:solidFill>
                   <a:srgbClr val="0F172A"/>
                 </a:solidFill>
+                <a:latin typeface="Calibri"/>
               </a:defRPr>
             </a:pPr>
             <a:r>
@@ -5273,6 +5361,7 @@
                 <a:solidFill>
                   <a:srgbClr val="334155"/>
                 </a:solidFill>
+                <a:latin typeface="Calibri"/>
               </a:defRPr>
             </a:pPr>
             <a:r>
@@ -5288,6 +5377,7 @@
                 <a:solidFill>
                   <a:srgbClr val="334155"/>
                 </a:solidFill>
+                <a:latin typeface="Calibri"/>
               </a:defRPr>
             </a:pPr>
             <a:r>
@@ -5303,6 +5393,7 @@
                 <a:solidFill>
                   <a:srgbClr val="334155"/>
                 </a:solidFill>
+                <a:latin typeface="Calibri"/>
               </a:defRPr>
             </a:pPr>
             <a:r>
@@ -5318,6 +5409,7 @@
                 <a:solidFill>
                   <a:srgbClr val="334155"/>
                 </a:solidFill>
+                <a:latin typeface="Calibri"/>
               </a:defRPr>
             </a:pPr>
             <a:r>
@@ -5367,7 +5459,11 @@
           <a:bodyPr rtlCol="0" anchor="ctr"/>
           <a:lstStyle/>
           <a:p>
-            <a:pPr algn="ctr"/>
+            <a:pPr algn="ctr">
+              <a:defRPr>
+                <a:latin typeface="Calibri"/>
+              </a:defRPr>
+            </a:pPr>
           </a:p>
         </p:txBody>
       </p:sp>
@@ -5451,6 +5547,7 @@
                 <a:solidFill>
                   <a:srgbClr val="0F172A"/>
                 </a:solidFill>
+                <a:latin typeface="Calibri"/>
               </a:defRPr>
             </a:pPr>
             <a:r>
@@ -5466,6 +5563,7 @@
                 <a:solidFill>
                   <a:srgbClr val="334155"/>
                 </a:solidFill>
+                <a:latin typeface="Calibri"/>
               </a:defRPr>
             </a:pPr>
             <a:r>
@@ -5481,6 +5579,7 @@
                 <a:solidFill>
                   <a:srgbClr val="334155"/>
                 </a:solidFill>
+                <a:latin typeface="Calibri"/>
               </a:defRPr>
             </a:pPr>
             <a:r>
@@ -5496,6 +5595,7 @@
                 <a:solidFill>
                   <a:srgbClr val="334155"/>
                 </a:solidFill>
+                <a:latin typeface="Calibri"/>
               </a:defRPr>
             </a:pPr>
             <a:r>
@@ -5511,6 +5611,7 @@
                 <a:solidFill>
                   <a:srgbClr val="334155"/>
                 </a:solidFill>
+                <a:latin typeface="Calibri"/>
               </a:defRPr>
             </a:pPr>
             <a:r>
@@ -5560,7 +5661,11 @@
           <a:bodyPr rtlCol="0" anchor="ctr"/>
           <a:lstStyle/>
           <a:p>
-            <a:pPr algn="ctr"/>
+            <a:pPr algn="ctr">
+              <a:defRPr>
+                <a:latin typeface="Calibri"/>
+              </a:defRPr>
+            </a:pPr>
           </a:p>
         </p:txBody>
       </p:sp>
@@ -5710,7 +5815,11 @@
           <a:bodyPr rtlCol="0" anchor="ctr"/>
           <a:lstStyle/>
           <a:p>
-            <a:pPr algn="ctr"/>
+            <a:pPr algn="ctr">
+              <a:defRPr>
+                <a:latin typeface="Calibri"/>
+              </a:defRPr>
+            </a:pPr>
           </a:p>
         </p:txBody>
       </p:sp>
@@ -5863,7 +5972,11 @@
           <a:bodyPr rtlCol="0" anchor="ctr"/>
           <a:lstStyle/>
           <a:p>
-            <a:pPr algn="ctr"/>
+            <a:pPr algn="ctr">
+              <a:defRPr>
+                <a:latin typeface="Calibri"/>
+              </a:defRPr>
+            </a:pPr>
           </a:p>
         </p:txBody>
       </p:sp>
@@ -5947,6 +6060,7 @@
                 <a:solidFill>
                   <a:srgbClr val="0F172A"/>
                 </a:solidFill>
+                <a:latin typeface="Calibri"/>
               </a:defRPr>
             </a:pPr>
             <a:r>
@@ -5962,6 +6076,7 @@
                 <a:solidFill>
                   <a:srgbClr val="EA580C"/>
                 </a:solidFill>
+                <a:latin typeface="Calibri"/>
               </a:defRPr>
             </a:pPr>
             <a:r>
@@ -5977,6 +6092,7 @@
                 <a:solidFill>
                   <a:srgbClr val="334155"/>
                 </a:solidFill>
+                <a:latin typeface="Calibri"/>
               </a:defRPr>
             </a:pPr>
             <a:r>
@@ -5992,6 +6108,7 @@
                 <a:solidFill>
                   <a:srgbClr val="0F172A"/>
                 </a:solidFill>
+                <a:latin typeface="Calibri"/>
               </a:defRPr>
             </a:pPr>
             <a:r>
@@ -6041,7 +6158,11 @@
           <a:bodyPr rtlCol="0" anchor="ctr"/>
           <a:lstStyle/>
           <a:p>
-            <a:pPr algn="ctr"/>
+            <a:pPr algn="ctr">
+              <a:defRPr>
+                <a:latin typeface="Calibri"/>
+              </a:defRPr>
+            </a:pPr>
           </a:p>
         </p:txBody>
       </p:sp>
@@ -6125,6 +6246,7 @@
                 <a:solidFill>
                   <a:srgbClr val="0F172A"/>
                 </a:solidFill>
+                <a:latin typeface="Calibri"/>
               </a:defRPr>
             </a:pPr>
             <a:r>
@@ -6140,6 +6262,7 @@
                 <a:solidFill>
                   <a:srgbClr val="334155"/>
                 </a:solidFill>
+                <a:latin typeface="Calibri"/>
               </a:defRPr>
             </a:pPr>
             <a:r>
@@ -6155,6 +6278,7 @@
                 <a:solidFill>
                   <a:srgbClr val="334155"/>
                 </a:solidFill>
+                <a:latin typeface="Calibri"/>
               </a:defRPr>
             </a:pPr>
             <a:r>
@@ -6170,6 +6294,7 @@
                 <a:solidFill>
                   <a:srgbClr val="334155"/>
                 </a:solidFill>
+                <a:latin typeface="Calibri"/>
               </a:defRPr>
             </a:pPr>
             <a:r>
@@ -6185,6 +6310,7 @@
                 <a:solidFill>
                   <a:srgbClr val="334155"/>
                 </a:solidFill>
+                <a:latin typeface="Calibri"/>
               </a:defRPr>
             </a:pPr>
             <a:r>
@@ -6234,7 +6360,11 @@
           <a:bodyPr rtlCol="0" anchor="ctr"/>
           <a:lstStyle/>
           <a:p>
-            <a:pPr algn="ctr"/>
+            <a:pPr algn="ctr">
+              <a:defRPr>
+                <a:latin typeface="Calibri"/>
+              </a:defRPr>
+            </a:pPr>
           </a:p>
         </p:txBody>
       </p:sp>
@@ -6318,6 +6448,7 @@
                 <a:solidFill>
                   <a:srgbClr val="0F172A"/>
                 </a:solidFill>
+                <a:latin typeface="Calibri"/>
               </a:defRPr>
             </a:pPr>
             <a:r>
@@ -6333,6 +6464,7 @@
                 <a:solidFill>
                   <a:srgbClr val="334155"/>
                 </a:solidFill>
+                <a:latin typeface="Calibri"/>
               </a:defRPr>
             </a:pPr>
             <a:r>
@@ -6348,6 +6480,7 @@
                 <a:solidFill>
                   <a:srgbClr val="334155"/>
                 </a:solidFill>
+                <a:latin typeface="Calibri"/>
               </a:defRPr>
             </a:pPr>
             <a:r>
@@ -6363,6 +6496,7 @@
                 <a:solidFill>
                   <a:srgbClr val="334155"/>
                 </a:solidFill>
+                <a:latin typeface="Calibri"/>
               </a:defRPr>
             </a:pPr>
             <a:r>
@@ -6378,6 +6512,7 @@
                 <a:solidFill>
                   <a:srgbClr val="334155"/>
                 </a:solidFill>
+                <a:latin typeface="Calibri"/>
               </a:defRPr>
             </a:pPr>
             <a:r>
@@ -6427,7 +6562,11 @@
           <a:bodyPr rtlCol="0" anchor="ctr"/>
           <a:lstStyle/>
           <a:p>
-            <a:pPr algn="ctr"/>
+            <a:pPr algn="ctr">
+              <a:defRPr>
+                <a:latin typeface="Calibri"/>
+              </a:defRPr>
+            </a:pPr>
           </a:p>
         </p:txBody>
       </p:sp>
@@ -6577,7 +6716,11 @@
           <a:bodyPr rtlCol="0" anchor="ctr"/>
           <a:lstStyle/>
           <a:p>
-            <a:pPr algn="ctr"/>
+            <a:pPr algn="ctr">
+              <a:defRPr>
+                <a:latin typeface="Calibri"/>
+              </a:defRPr>
+            </a:pPr>
           </a:p>
         </p:txBody>
       </p:sp>
@@ -6730,7 +6873,11 @@
           <a:bodyPr rtlCol="0" anchor="ctr"/>
           <a:lstStyle/>
           <a:p>
-            <a:pPr algn="ctr"/>
+            <a:pPr algn="ctr">
+              <a:defRPr>
+                <a:latin typeface="Calibri"/>
+              </a:defRPr>
+            </a:pPr>
           </a:p>
         </p:txBody>
       </p:sp>
@@ -6814,6 +6961,7 @@
                 <a:solidFill>
                   <a:srgbClr val="0F172A"/>
                 </a:solidFill>
+                <a:latin typeface="Calibri"/>
               </a:defRPr>
             </a:pPr>
             <a:r>
@@ -6829,6 +6977,7 @@
                 <a:solidFill>
                   <a:srgbClr val="991B1B"/>
                 </a:solidFill>
+                <a:latin typeface="Calibri"/>
               </a:defRPr>
             </a:pPr>
             <a:r>
@@ -6844,6 +6993,7 @@
                 <a:solidFill>
                   <a:srgbClr val="166534"/>
                 </a:solidFill>
+                <a:latin typeface="Calibri"/>
               </a:defRPr>
             </a:pPr>
             <a:r>
@@ -6893,7 +7043,11 @@
           <a:bodyPr rtlCol="0" anchor="ctr"/>
           <a:lstStyle/>
           <a:p>
-            <a:pPr algn="ctr"/>
+            <a:pPr algn="ctr">
+              <a:defRPr>
+                <a:latin typeface="Calibri"/>
+              </a:defRPr>
+            </a:pPr>
           </a:p>
         </p:txBody>
       </p:sp>
@@ -6977,6 +7131,7 @@
                 <a:solidFill>
                   <a:srgbClr val="0F172A"/>
                 </a:solidFill>
+                <a:latin typeface="Calibri"/>
               </a:defRPr>
             </a:pPr>
             <a:r>
@@ -6992,6 +7147,7 @@
                 <a:solidFill>
                   <a:srgbClr val="991B1B"/>
                 </a:solidFill>
+                <a:latin typeface="Calibri"/>
               </a:defRPr>
             </a:pPr>
             <a:r>
@@ -7007,6 +7163,7 @@
                 <a:solidFill>
                   <a:srgbClr val="166534"/>
                 </a:solidFill>
+                <a:latin typeface="Calibri"/>
               </a:defRPr>
             </a:pPr>
             <a:r>
@@ -7056,7 +7213,11 @@
           <a:bodyPr rtlCol="0" anchor="ctr"/>
           <a:lstStyle/>
           <a:p>
-            <a:pPr algn="ctr"/>
+            <a:pPr algn="ctr">
+              <a:defRPr>
+                <a:latin typeface="Calibri"/>
+              </a:defRPr>
+            </a:pPr>
           </a:p>
         </p:txBody>
       </p:sp>
@@ -7140,6 +7301,7 @@
                 <a:solidFill>
                   <a:srgbClr val="0F172A"/>
                 </a:solidFill>
+                <a:latin typeface="Calibri"/>
               </a:defRPr>
             </a:pPr>
             <a:r>
@@ -7155,6 +7317,7 @@
                 <a:solidFill>
                   <a:srgbClr val="991B1B"/>
                 </a:solidFill>
+                <a:latin typeface="Calibri"/>
               </a:defRPr>
             </a:pPr>
             <a:r>
@@ -7170,6 +7333,7 @@
                 <a:solidFill>
                   <a:srgbClr val="166534"/>
                 </a:solidFill>
+                <a:latin typeface="Calibri"/>
               </a:defRPr>
             </a:pPr>
             <a:r>
@@ -7219,7 +7383,11 @@
           <a:bodyPr rtlCol="0" anchor="ctr"/>
           <a:lstStyle/>
           <a:p>
-            <a:pPr algn="ctr"/>
+            <a:pPr algn="ctr">
+              <a:defRPr>
+                <a:latin typeface="Calibri"/>
+              </a:defRPr>
+            </a:pPr>
           </a:p>
         </p:txBody>
       </p:sp>
@@ -7303,6 +7471,7 @@
                 <a:solidFill>
                   <a:srgbClr val="0F172A"/>
                 </a:solidFill>
+                <a:latin typeface="Calibri"/>
               </a:defRPr>
             </a:pPr>
             <a:r>
@@ -7318,6 +7487,7 @@
                 <a:solidFill>
                   <a:srgbClr val="991B1B"/>
                 </a:solidFill>
+                <a:latin typeface="Calibri"/>
               </a:defRPr>
             </a:pPr>
             <a:r>
@@ -7333,6 +7503,7 @@
                 <a:solidFill>
                   <a:srgbClr val="166534"/>
                 </a:solidFill>
+                <a:latin typeface="Calibri"/>
               </a:defRPr>
             </a:pPr>
             <a:r>
@@ -7382,7 +7553,11 @@
           <a:bodyPr rtlCol="0" anchor="ctr"/>
           <a:lstStyle/>
           <a:p>
-            <a:pPr algn="ctr"/>
+            <a:pPr algn="ctr">
+              <a:defRPr>
+                <a:latin typeface="Calibri"/>
+              </a:defRPr>
+            </a:pPr>
           </a:p>
         </p:txBody>
       </p:sp>
@@ -7466,6 +7641,7 @@
                 <a:solidFill>
                   <a:srgbClr val="0F172A"/>
                 </a:solidFill>
+                <a:latin typeface="Calibri"/>
               </a:defRPr>
             </a:pPr>
             <a:r>
@@ -7481,6 +7657,7 @@
                 <a:solidFill>
                   <a:srgbClr val="991B1B"/>
                 </a:solidFill>
+                <a:latin typeface="Calibri"/>
               </a:defRPr>
             </a:pPr>
             <a:r>
@@ -7496,6 +7673,7 @@
                 <a:solidFill>
                   <a:srgbClr val="166534"/>
                 </a:solidFill>
+                <a:latin typeface="Calibri"/>
               </a:defRPr>
             </a:pPr>
             <a:r>
@@ -7545,7 +7723,11 @@
           <a:bodyPr rtlCol="0" anchor="ctr"/>
           <a:lstStyle/>
           <a:p>
-            <a:pPr algn="ctr"/>
+            <a:pPr algn="ctr">
+              <a:defRPr>
+                <a:latin typeface="Calibri"/>
+              </a:defRPr>
+            </a:pPr>
           </a:p>
         </p:txBody>
       </p:sp>
@@ -7629,6 +7811,7 @@
                 <a:solidFill>
                   <a:srgbClr val="0F172A"/>
                 </a:solidFill>
+                <a:latin typeface="Calibri"/>
               </a:defRPr>
             </a:pPr>
             <a:r>
@@ -7644,6 +7827,7 @@
                 <a:solidFill>
                   <a:srgbClr val="991B1B"/>
                 </a:solidFill>
+                <a:latin typeface="Calibri"/>
               </a:defRPr>
             </a:pPr>
             <a:r>
@@ -7659,6 +7843,7 @@
                 <a:solidFill>
                   <a:srgbClr val="166534"/>
                 </a:solidFill>
+                <a:latin typeface="Calibri"/>
               </a:defRPr>
             </a:pPr>
             <a:r>
@@ -7708,7 +7893,11 @@
           <a:bodyPr rtlCol="0" anchor="ctr"/>
           <a:lstStyle/>
           <a:p>
-            <a:pPr algn="ctr"/>
+            <a:pPr algn="ctr">
+              <a:defRPr>
+                <a:latin typeface="Calibri"/>
+              </a:defRPr>
+            </a:pPr>
           </a:p>
         </p:txBody>
       </p:sp>
@@ -7858,7 +8047,11 @@
           <a:bodyPr rtlCol="0" anchor="ctr"/>
           <a:lstStyle/>
           <a:p>
-            <a:pPr algn="ctr"/>
+            <a:pPr algn="ctr">
+              <a:defRPr>
+                <a:latin typeface="Calibri"/>
+              </a:defRPr>
+            </a:pPr>
           </a:p>
         </p:txBody>
       </p:sp>
@@ -8011,7 +8204,11 @@
           <a:bodyPr rtlCol="0" anchor="ctr"/>
           <a:lstStyle/>
           <a:p>
-            <a:pPr algn="ctr"/>
+            <a:pPr algn="ctr">
+              <a:defRPr>
+                <a:latin typeface="Calibri"/>
+              </a:defRPr>
+            </a:pPr>
           </a:p>
         </p:txBody>
       </p:sp>
@@ -8095,6 +8292,7 @@
                 <a:solidFill>
                   <a:srgbClr val="0F172A"/>
                 </a:solidFill>
+                <a:latin typeface="Calibri"/>
               </a:defRPr>
             </a:pPr>
             <a:r>
@@ -8110,6 +8308,7 @@
                 <a:solidFill>
                   <a:srgbClr val="2563EB"/>
                 </a:solidFill>
+                <a:latin typeface="Calibri"/>
               </a:defRPr>
             </a:pPr>
             <a:r>
@@ -8125,6 +8324,7 @@
                 <a:solidFill>
                   <a:srgbClr val="334155"/>
                 </a:solidFill>
+                <a:latin typeface="Calibri"/>
               </a:defRPr>
             </a:pPr>
             <a:r>
@@ -8140,6 +8340,7 @@
                 <a:solidFill>
                   <a:srgbClr val="2563EB"/>
                 </a:solidFill>
+                <a:latin typeface="Calibri"/>
               </a:defRPr>
             </a:pPr>
             <a:r>
@@ -8155,6 +8356,7 @@
                 <a:solidFill>
                   <a:srgbClr val="334155"/>
                 </a:solidFill>
+                <a:latin typeface="Calibri"/>
               </a:defRPr>
             </a:pPr>
             <a:r>
@@ -8170,6 +8372,7 @@
                 <a:solidFill>
                   <a:srgbClr val="2563EB"/>
                 </a:solidFill>
+                <a:latin typeface="Calibri"/>
               </a:defRPr>
             </a:pPr>
             <a:r>
@@ -8185,6 +8388,7 @@
                 <a:solidFill>
                   <a:srgbClr val="334155"/>
                 </a:solidFill>
+                <a:latin typeface="Calibri"/>
               </a:defRPr>
             </a:pPr>
             <a:r>
@@ -8200,6 +8404,7 @@
                 <a:solidFill>
                   <a:srgbClr val="2563EB"/>
                 </a:solidFill>
+                <a:latin typeface="Calibri"/>
               </a:defRPr>
             </a:pPr>
             <a:r>
@@ -8215,6 +8420,7 @@
                 <a:solidFill>
                   <a:srgbClr val="334155"/>
                 </a:solidFill>
+                <a:latin typeface="Calibri"/>
               </a:defRPr>
             </a:pPr>
             <a:r>
@@ -8230,6 +8436,7 @@
                 <a:solidFill>
                   <a:srgbClr val="2563EB"/>
                 </a:solidFill>
+                <a:latin typeface="Calibri"/>
               </a:defRPr>
             </a:pPr>
             <a:r>
@@ -8245,6 +8452,7 @@
                 <a:solidFill>
                   <a:srgbClr val="334155"/>
                 </a:solidFill>
+                <a:latin typeface="Calibri"/>
               </a:defRPr>
             </a:pPr>
             <a:r>
@@ -8294,7 +8502,11 @@
           <a:bodyPr rtlCol="0" anchor="ctr"/>
           <a:lstStyle/>
           <a:p>
-            <a:pPr algn="ctr"/>
+            <a:pPr algn="ctr">
+              <a:defRPr>
+                <a:latin typeface="Calibri"/>
+              </a:defRPr>
+            </a:pPr>
           </a:p>
         </p:txBody>
       </p:sp>
@@ -8378,6 +8590,7 @@
                 <a:solidFill>
                   <a:srgbClr val="0F172A"/>
                 </a:solidFill>
+                <a:latin typeface="Calibri"/>
               </a:defRPr>
             </a:pPr>
             <a:r>
@@ -8393,6 +8606,7 @@
                 <a:solidFill>
                   <a:srgbClr val="334155"/>
                 </a:solidFill>
+                <a:latin typeface="Calibri"/>
               </a:defRPr>
             </a:pPr>
             <a:r>
@@ -8408,6 +8622,7 @@
                 <a:solidFill>
                   <a:srgbClr val="334155"/>
                 </a:solidFill>
+                <a:latin typeface="Calibri"/>
               </a:defRPr>
             </a:pPr>
             <a:r>
@@ -8423,6 +8638,7 @@
                 <a:solidFill>
                   <a:srgbClr val="334155"/>
                 </a:solidFill>
+                <a:latin typeface="Calibri"/>
               </a:defRPr>
             </a:pPr>
             <a:r>
@@ -8438,6 +8654,7 @@
                 <a:solidFill>
                   <a:srgbClr val="334155"/>
                 </a:solidFill>
+                <a:latin typeface="Calibri"/>
               </a:defRPr>
             </a:pPr>
             <a:r>
@@ -8453,6 +8670,7 @@
                 <a:solidFill>
                   <a:srgbClr val="334155"/>
                 </a:solidFill>
+                <a:latin typeface="Calibri"/>
               </a:defRPr>
             </a:pPr>
             <a:r>
@@ -8468,6 +8686,7 @@
                 <a:solidFill>
                   <a:srgbClr val="334155"/>
                 </a:solidFill>
+                <a:latin typeface="Calibri"/>
               </a:defRPr>
             </a:pPr>
             <a:r>
@@ -8483,6 +8702,7 @@
                 <a:solidFill>
                   <a:srgbClr val="334155"/>
                 </a:solidFill>
+                <a:latin typeface="Calibri"/>
               </a:defRPr>
             </a:pPr>
             <a:r>
@@ -8498,6 +8718,7 @@
                 <a:solidFill>
                   <a:srgbClr val="334155"/>
                 </a:solidFill>
+                <a:latin typeface="Calibri"/>
               </a:defRPr>
             </a:pPr>
             <a:r>
@@ -8547,7 +8768,11 @@
           <a:bodyPr rtlCol="0" anchor="ctr"/>
           <a:lstStyle/>
           <a:p>
-            <a:pPr algn="ctr"/>
+            <a:pPr algn="ctr">
+              <a:defRPr>
+                <a:latin typeface="Calibri"/>
+              </a:defRPr>
+            </a:pPr>
           </a:p>
         </p:txBody>
       </p:sp>

</xml_diff>

<commit_message>
feat(review1): Refactor research paper plan to publication-ready manuscript targeting peer-reviewed venues without rigid Q1 commitments
</commit_message>
<xml_diff>
--- a/review_1_main/Slides_Muc_8_9_10_11_12.pptx
+++ b/review_1_main/Slides_Muc_8_9_10_11_12.pptx
@@ -5025,7 +5025,7 @@
               </a:defRPr>
             </a:pPr>
             <a:r>
-              <a:t>RTSP camera pipeline, Docker packaging, IEEE paper polish.</a:t>
+              <a:t>RTSP camera pipeline, Docker packaging, Scientific paper polish.</a:t>
             </a:r>
           </a:p>
           <a:p>
@@ -5567,7 +5567,7 @@
               </a:defRPr>
             </a:pPr>
             <a:r>
-              <a:t>• Nguyễn Hàn Như (Lead · SE183644): Overall network architecture, custom PyTorch modules, and IEEE paper writing.</a:t>
+              <a:t>• Nguyễn Hàn Như (Lead · SE183644): Overall network architecture, custom PyTorch modules, and Scientific paper writing.</a:t>
             </a:r>
           </a:p>
           <a:p>
@@ -5854,7 +5854,7 @@
               </a:defRPr>
             </a:pPr>
             <a:r>
-              <a:t>CRITERION 6 · RESEARCH PAPER PLAN (IEEE TRANSACTIONS)</a:t>
+              <a:t>CRITERION 6 · SCIENTIFIC RESEARCH &amp; PUBLICATION PLAN</a:t>
             </a:r>
           </a:p>
         </p:txBody>
@@ -5926,7 +5926,7 @@
               </a:defRPr>
             </a:pPr>
             <a:r>
-              <a:t>Scientific Publication Plan: Targeting IEEE Transactions (Q1)</a:t>
+              <a:t>Scientific Research Manuscript: Publication-Ready Paper Plan</a:t>
             </a:r>
           </a:p>
         </p:txBody>
@@ -5989,7 +5989,7 @@
         <p:spPr>
           <a:xfrm>
             <a:off x="914400" y="1353312"/>
-            <a:ext cx="2377440" cy="292608"/>
+            <a:ext cx="3291840" cy="292608"/>
           </a:xfrm>
           <a:prstGeom prst="roundRect">
             <a:avLst/>
@@ -6028,7 +6028,7 @@
               </a:defRPr>
             </a:pPr>
             <a:r>
-              <a:t>TARGET PUBLICATION VENUE</a:t>
+              <a:t>SCIENTIFIC MANUSCRIPT &amp; ACADEMIC STANDARDS</a:t>
             </a:r>
           </a:p>
         </p:txBody>
@@ -6064,7 +6064,7 @@
               </a:defRPr>
             </a:pPr>
             <a:r>
-              <a:t>IEEE Transactions on Industrial Informatics (IEEE TII) — Q1 Top-Tier</a:t>
+              <a:t>Publication-Ready Master Manuscript (Targeting Peer-Reviewed Venues)</a:t>
             </a:r>
           </a:p>
           <a:p>
@@ -6080,7 +6080,7 @@
               </a:defRPr>
             </a:pPr>
             <a:r>
-              <a:t>Impact Factor: 11.7 · CiteScore: 21.0 · Alternative Targets: IEEE TPAMI / IEEE TIM</a:t>
+              <a:t>Formatted in Standard IEEE Double-Column · Ready for Academic Committee Review &amp; Journal Submission</a:t>
             </a:r>
           </a:p>
           <a:p>
@@ -6112,7 +6112,7 @@
               </a:defRPr>
             </a:pPr>
             <a:r>
-              <a:t>• Manuscript Status: 10-page master research paper fully drafted in IEEEtran format (Rep-YOLO11s_Master_Paper_IEEE.pdf).</a:t>
+              <a:t>• Manuscript Status: Complete 10-page master technical paper fully drafted in IEEE format, ready for Academic Council evaluation and journal submission.</a:t>
             </a:r>
           </a:p>
         </p:txBody>
@@ -6484,7 +6484,7 @@
               </a:defRPr>
             </a:pPr>
             <a:r>
-              <a:t>• Phase 4 (Writing &amp; Peer Review): Rigorous academic polishing, IEEE LaTeX double-column typesetting, and mentor co-author review.</a:t>
+              <a:t>• Phase 4 (Writing &amp; Academic Review): Rigorous academic polishing, IEEE LaTeX double-column typesetting, and mentor co-author review.</a:t>
             </a:r>
           </a:p>
           <a:p>
@@ -6500,7 +6500,7 @@
               </a:defRPr>
             </a:pPr>
             <a:r>
-              <a:t>• Phase 5 &amp; Post-Defense: Formal journal submission to IEEE Transactions; public release of models and datasets on GitHub.</a:t>
+              <a:t>• Phase 5 &amp; Defense: Present manuscript to Academic Council; finalize submission to reputable journals/conferences under advisor mentorship.</a:t>
             </a:r>
           </a:p>
           <a:p>
@@ -6654,7 +6654,7 @@
               </a:defRPr>
             </a:pPr>
             <a:r>
-              <a:t>Publication-grade research combining mathematical proofs, extensive empirical evidence, and open-source industrial contributions.</a:t>
+              <a:t>Publication-ready scientific manuscript prepared to international IEEE standards, fully verifiable by the Academic Council and ready for peer-reviewed venues.</a:t>
             </a:r>
           </a:p>
         </p:txBody>
@@ -8440,7 +8440,7 @@
               </a:defRPr>
             </a:pPr>
             <a:r>
-              <a:t>5. IEEE Q1 Research Manuscript</a:t>
+              <a:t>5. Scientific Research Manuscript</a:t>
             </a:r>
           </a:p>
           <a:p>
@@ -8456,7 +8456,7 @@
               </a:defRPr>
             </a:pPr>
             <a:r>
-              <a:t>10-page master paper ready for submission to IEEE Transactions on Industrial Informatics (IEEE TII).</a:t>
+              <a:t>Publication-ready master paper in IEEE format, ready for Academic Council evaluation and journal submission.</a:t>
             </a:r>
           </a:p>
         </p:txBody>
@@ -8860,7 +8860,7 @@
               </a:defRPr>
             </a:pPr>
             <a:r>
-              <a:t>A comprehensive, publication-grade AI capstone delivering high-accuracy helmet surveillance, robust software, and IEEE Q1 contribution.</a:t>
+              <a:t>A comprehensive, publication-grade AI capstone delivering high-accuracy helmet surveillance, robust software, and verifiable scientific contributions.</a:t>
             </a:r>
           </a:p>
         </p:txBody>

</xml_diff>